<commit_message>
Añadir tutorías en LAB1 y retirar la diapositiva final de errores
</commit_message>
<xml_diff>
--- a/26/Lógica Computacional/LAB1/LAB1_Introduccion_a_Prolog.pptx
+++ b/26/Lógica Computacional/LAB1/LAB1_Introduccion_a_Prolog.pptx
@@ -9,6 +9,7 @@
   </p:notesMasterIdLst>
   <p:sldIdLst>
     <p:sldId xmlns:r="http://schemas.openxmlformats.org/officeDocument/2006/relationships" id="256" r:id="R7659403b494c4aa4"/>
+    <p:sldId xmlns:r="http://schemas.openxmlformats.org/officeDocument/2006/relationships" id="295" r:id="Ra4df9922c4234bd3"/>
     <p:sldId xmlns:r="http://schemas.openxmlformats.org/officeDocument/2006/relationships" id="257" r:id="R9fb27439572246eb"/>
     <p:sldId xmlns:r="http://schemas.openxmlformats.org/officeDocument/2006/relationships" id="258" r:id="Rc8690086080b4782"/>
     <p:sldId xmlns:r="http://schemas.openxmlformats.org/officeDocument/2006/relationships" id="259" r:id="R94aa058f30e549db"/>
@@ -47,7 +48,6 @@
     <p:sldId xmlns:r="http://schemas.openxmlformats.org/officeDocument/2006/relationships" id="292" r:id="Re66f2a47609141c7"/>
     <p:sldId xmlns:r="http://schemas.openxmlformats.org/officeDocument/2006/relationships" id="293" r:id="Rd5ea7b93c887475f"/>
     <p:sldId xmlns:r="http://schemas.openxmlformats.org/officeDocument/2006/relationships" id="294" r:id="R5702867364e9440a"/>
-    <p:sldId xmlns:r="http://schemas.openxmlformats.org/officeDocument/2006/relationships" id="295" r:id="Ra4df9922c4234bd3"/>
   </p:sldIdLst>
   <p:sldSz cx="11704320" cy="6583680"/>
   <p:notesSz cx="6858000" cy="9144000"/>
@@ -4653,7 +4653,7 @@
                 <a:ea typeface="Arial"/>
                 <a:cs typeface="Arial"/>
               </a:rPr>
-              <a:t>10</a:t>
+              <a:t>11</a:t>
             </a:r>
           </a:p>
         </p:txBody>
@@ -5302,7 +5302,7 @@
                 <a:ea typeface="Arial"/>
                 <a:cs typeface="Arial"/>
               </a:rPr>
-              <a:t>11</a:t>
+              <a:t>12</a:t>
             </a:r>
           </a:p>
         </p:txBody>
@@ -6122,7 +6122,7 @@
                 <a:ea typeface="Arial"/>
                 <a:cs typeface="Arial"/>
               </a:rPr>
-              <a:t>12</a:t>
+              <a:t>13</a:t>
             </a:r>
           </a:p>
         </p:txBody>
@@ -6755,7 +6755,7 @@
                 <a:ea typeface="Arial"/>
                 <a:cs typeface="Arial"/>
               </a:rPr>
-              <a:t>13</a:t>
+              <a:t>14</a:t>
             </a:r>
           </a:p>
         </p:txBody>
@@ -7599,7 +7599,7 @@
                 <a:ea typeface="Arial"/>
                 <a:cs typeface="Arial"/>
               </a:rPr>
-              <a:t>14</a:t>
+              <a:t>15</a:t>
             </a:r>
           </a:p>
         </p:txBody>
@@ -8558,7 +8558,7 @@
                 <a:ea typeface="Arial"/>
                 <a:cs typeface="Arial"/>
               </a:rPr>
-              <a:t>15</a:t>
+              <a:t>16</a:t>
             </a:r>
           </a:p>
         </p:txBody>
@@ -9308,7 +9308,7 @@
                 <a:ea typeface="Arial"/>
                 <a:cs typeface="Arial"/>
               </a:rPr>
-              <a:t>16</a:t>
+              <a:t>17</a:t>
             </a:r>
           </a:p>
         </p:txBody>
@@ -9929,7 +9929,7 @@
                 <a:ea typeface="Arial"/>
                 <a:cs typeface="Arial"/>
               </a:rPr>
-              <a:t>17</a:t>
+              <a:t>18</a:t>
             </a:r>
           </a:p>
         </p:txBody>
@@ -10550,7 +10550,7 @@
                 <a:ea typeface="Arial"/>
                 <a:cs typeface="Arial"/>
               </a:rPr>
-              <a:t>18</a:t>
+              <a:t>19</a:t>
             </a:r>
           </a:p>
         </p:txBody>
@@ -11395,7 +11395,7 @@
                 <a:ea typeface="Arial"/>
                 <a:cs typeface="Arial"/>
               </a:rPr>
-              <a:t>19</a:t>
+              <a:t>20</a:t>
             </a:r>
           </a:p>
         </p:txBody>
@@ -12825,7 +12825,7 @@
                 <a:ea typeface="Arial"/>
                 <a:cs typeface="Arial"/>
               </a:rPr>
-              <a:t>2</a:t>
+              <a:t>3</a:t>
             </a:r>
           </a:p>
         </p:txBody>
@@ -13444,7 +13444,7 @@
                 <a:ea typeface="Arial"/>
                 <a:cs typeface="Arial"/>
               </a:rPr>
-              <a:t>20</a:t>
+              <a:t>21</a:t>
             </a:r>
           </a:p>
         </p:txBody>
@@ -14125,7 +14125,7 @@
                 <a:ea typeface="Arial"/>
                 <a:cs typeface="Arial"/>
               </a:rPr>
-              <a:t>21</a:t>
+              <a:t>22</a:t>
             </a:r>
           </a:p>
         </p:txBody>
@@ -14894,7 +14894,7 @@
                 <a:ea typeface="Arial"/>
                 <a:cs typeface="Arial"/>
               </a:rPr>
-              <a:t>22</a:t>
+              <a:t>23</a:t>
             </a:r>
           </a:p>
         </p:txBody>
@@ -15572,7 +15572,7 @@
                 <a:ea typeface="Arial"/>
                 <a:cs typeface="Arial"/>
               </a:rPr>
-              <a:t>23</a:t>
+              <a:t>24</a:t>
             </a:r>
           </a:p>
         </p:txBody>
@@ -16203,7 +16203,7 @@
                 <a:ea typeface="Arial"/>
                 <a:cs typeface="Arial"/>
               </a:rPr>
-              <a:t>24</a:t>
+              <a:t>25</a:t>
             </a:r>
           </a:p>
         </p:txBody>
@@ -17495,7 +17495,7 @@
                 <a:ea typeface="Arial"/>
                 <a:cs typeface="Arial"/>
               </a:rPr>
-              <a:t>25</a:t>
+              <a:t>26</a:t>
             </a:r>
           </a:p>
         </p:txBody>
@@ -18139,7 +18139,7 @@
                 <a:ea typeface="Arial"/>
                 <a:cs typeface="Arial"/>
               </a:rPr>
-              <a:t>26</a:t>
+              <a:t>27</a:t>
             </a:r>
           </a:p>
         </p:txBody>
@@ -18931,7 +18931,7 @@
                 <a:ea typeface="Arial"/>
                 <a:cs typeface="Arial"/>
               </a:rPr>
-              <a:t>27</a:t>
+              <a:t>28</a:t>
             </a:r>
           </a:p>
         </p:txBody>
@@ -19637,7 +19637,7 @@
                 <a:ea typeface="Arial"/>
                 <a:cs typeface="Arial"/>
               </a:rPr>
-              <a:t>28</a:t>
+              <a:t>29</a:t>
             </a:r>
           </a:p>
         </p:txBody>
@@ -20429,7 +20429,7 @@
                 <a:ea typeface="Arial"/>
                 <a:cs typeface="Arial"/>
               </a:rPr>
-              <a:t>29</a:t>
+              <a:t>30</a:t>
             </a:r>
           </a:p>
         </p:txBody>
@@ -21135,7 +21135,7 @@
                 <a:ea typeface="Arial"/>
                 <a:cs typeface="Arial"/>
               </a:rPr>
-              <a:t>3</a:t>
+              <a:t>4</a:t>
             </a:r>
           </a:p>
         </p:txBody>
@@ -21948,7 +21948,7 @@
                 <a:ea typeface="Arial"/>
                 <a:cs typeface="Arial"/>
               </a:rPr>
-              <a:t>30</a:t>
+              <a:t>31</a:t>
             </a:r>
           </a:p>
         </p:txBody>
@@ -22683,7 +22683,7 @@
                 <a:ea typeface="Arial"/>
                 <a:cs typeface="Arial"/>
               </a:rPr>
-              <a:t>31</a:t>
+              <a:t>32</a:t>
             </a:r>
           </a:p>
         </p:txBody>
@@ -23423,7 +23423,7 @@
                 <a:ea typeface="Arial"/>
                 <a:cs typeface="Arial"/>
               </a:rPr>
-              <a:t>32</a:t>
+              <a:t>33</a:t>
             </a:r>
           </a:p>
         </p:txBody>
@@ -24135,7 +24135,7 @@
                 <a:ea typeface="Arial"/>
                 <a:cs typeface="Arial"/>
               </a:rPr>
-              <a:t>33</a:t>
+              <a:t>34</a:t>
             </a:r>
           </a:p>
         </p:txBody>
@@ -24836,7 +24836,7 @@
                 <a:ea typeface="Arial"/>
                 <a:cs typeface="Arial"/>
               </a:rPr>
-              <a:t>34</a:t>
+              <a:t>35</a:t>
             </a:r>
           </a:p>
         </p:txBody>
@@ -25646,7 +25646,7 @@
                 <a:ea typeface="Arial"/>
                 <a:cs typeface="Arial"/>
               </a:rPr>
-              <a:t>35</a:t>
+              <a:t>36</a:t>
             </a:r>
           </a:p>
         </p:txBody>
@@ -26584,7 +26584,7 @@
                 <a:ea typeface="Arial"/>
                 <a:cs typeface="Arial"/>
               </a:rPr>
-              <a:t>36</a:t>
+              <a:t>37</a:t>
             </a:r>
           </a:p>
         </p:txBody>
@@ -27296,7 +27296,7 @@
                 <a:ea typeface="Arial"/>
                 <a:cs typeface="Arial"/>
               </a:rPr>
-              <a:t>37</a:t>
+              <a:t>38</a:t>
             </a:r>
           </a:p>
         </p:txBody>
@@ -27997,7 +27997,7 @@
                 <a:ea typeface="Arial"/>
                 <a:cs typeface="Arial"/>
               </a:rPr>
-              <a:t>38</a:t>
+              <a:t>39</a:t>
             </a:r>
           </a:p>
         </p:txBody>
@@ -28910,7 +28910,7 @@
                 <a:ea typeface="Arial"/>
                 <a:cs typeface="Arial"/>
               </a:rPr>
-              <a:t>39</a:t>
+              <a:t>40</a:t>
             </a:r>
           </a:p>
         </p:txBody>
@@ -29646,7 +29646,7 @@
                 <a:ea typeface="Arial"/>
                 <a:cs typeface="Arial"/>
               </a:rPr>
-              <a:t>4</a:t>
+              <a:t>5</a:t>
             </a:r>
           </a:p>
         </p:txBody>
@@ -30051,10 +30051,10 @@
       </p:grpSpPr>
       <p:sp>
         <p:nvSpPr>
-          <p:cNvPr id="10" name="">
-            <a:extLst xmlns:a="http://schemas.openxmlformats.org/drawingml/2006/main">
-              <a:ext uri="{FF2B5EF4-FFF2-40B4-BE49-F238E27FC236}">
-                <a16:creationId xmlns:a16="http://schemas.microsoft.com/office/drawing/2014/main" id="{BF85950B-4825-4323-81F5-34C3F4E1F9FE}"/>
+          <p:cNvPr id="13" name="">
+            <a:extLst xmlns:a="http://schemas.openxmlformats.org/drawingml/2006/main">
+              <a:ext uri="{FF2B5EF4-FFF2-40B4-BE49-F238E27FC236}">
+                <a16:creationId xmlns:a16="http://schemas.microsoft.com/office/drawing/2014/main" id="{81EF26E8-340C-4E14-AABB-85146EF7CC8F}"/>
               </a:ext>
             </a:extLst>
           </p:cNvPr>
@@ -30084,7 +30084,7 @@
           <p:cNvPr id="2" name="">
             <a:extLst xmlns:a="http://schemas.openxmlformats.org/drawingml/2006/main">
               <a:ext uri="{FF2B5EF4-FFF2-40B4-BE49-F238E27FC236}">
-                <a16:creationId xmlns:a16="http://schemas.microsoft.com/office/drawing/2014/main" id="{E47229D2-97AE-4E75-95C3-47F0F6D2980A}"/>
+                <a16:creationId xmlns:a16="http://schemas.microsoft.com/office/drawing/2014/main" id="{7ABFC343-6F76-42E9-96BD-310ABB0E5CFA}"/>
               </a:ext>
             </a:extLst>
           </p:cNvPr>
@@ -30114,7 +30114,7 @@
           <p:cNvPr id="3" name="">
             <a:extLst xmlns:a="http://schemas.openxmlformats.org/drawingml/2006/main">
               <a:ext uri="{FF2B5EF4-FFF2-40B4-BE49-F238E27FC236}">
-                <a16:creationId xmlns:a16="http://schemas.microsoft.com/office/drawing/2014/main" id="{3D5B8B85-41A5-48B6-B8AA-42DC15CBFEEE}"/>
+                <a16:creationId xmlns:a16="http://schemas.microsoft.com/office/drawing/2014/main" id="{CF878E92-4402-4C9C-BD46-36DCBF0E5A5B}"/>
               </a:ext>
             </a:extLst>
           </p:cNvPr>
@@ -30161,7 +30161,7 @@
                 <a:ea typeface="Arial"/>
                 <a:cs typeface="Arial"/>
               </a:rPr>
-              <a:t>Práctica 1 · 3 · Ejercicios</a:t>
+              <a:t>Práctica 1 · 1 · Preparación y lenguaje</a:t>
             </a:r>
           </a:p>
         </p:txBody>
@@ -30171,7 +30171,7 @@
           <p:cNvPr id="4" name="">
             <a:extLst xmlns:a="http://schemas.openxmlformats.org/drawingml/2006/main">
               <a:ext uri="{FF2B5EF4-FFF2-40B4-BE49-F238E27FC236}">
-                <a16:creationId xmlns:a16="http://schemas.microsoft.com/office/drawing/2014/main" id="{943D9EA1-3EAB-42E8-A60B-D63867668C2F}"/>
+                <a16:creationId xmlns:a16="http://schemas.microsoft.com/office/drawing/2014/main" id="{37094E80-2AAE-434B-9020-F26894343881}"/>
               </a:ext>
             </a:extLst>
           </p:cNvPr>
@@ -30218,7 +30218,7 @@
                 <a:ea typeface="Arial"/>
                 <a:cs typeface="Arial"/>
               </a:rPr>
-              <a:t>Ideas esenciales y errores habituales</a:t>
+              <a:t>Horario · Erik Figueiral Alonso</a:t>
             </a:r>
           </a:p>
         </p:txBody>
@@ -30228,7 +30228,7 @@
           <p:cNvPr id="5" name="">
             <a:extLst xmlns:a="http://schemas.openxmlformats.org/drawingml/2006/main">
               <a:ext uri="{FF2B5EF4-FFF2-40B4-BE49-F238E27FC236}">
-                <a16:creationId xmlns:a16="http://schemas.microsoft.com/office/drawing/2014/main" id="{DD0D4177-8E19-4911-B206-9DEEB28FF941}"/>
+                <a16:creationId xmlns:a16="http://schemas.microsoft.com/office/drawing/2014/main" id="{5686ACD4-81DB-480C-BD63-36E322765FD7}"/>
               </a:ext>
             </a:extLst>
           </p:cNvPr>
@@ -30285,7 +30285,7 @@
           <p:cNvPr id="6" name="">
             <a:extLst xmlns:a="http://schemas.openxmlformats.org/drawingml/2006/main">
               <a:ext uri="{FF2B5EF4-FFF2-40B4-BE49-F238E27FC236}">
-                <a16:creationId xmlns:a16="http://schemas.microsoft.com/office/drawing/2014/main" id="{FAF074E1-24C6-4CAB-84C0-2AD830857CA6}"/>
+                <a16:creationId xmlns:a16="http://schemas.microsoft.com/office/drawing/2014/main" id="{446B0959-DE31-4EA9-9039-5BFDA83845E6}"/>
               </a:ext>
             </a:extLst>
           </p:cNvPr>
@@ -30332,393 +30332,349 @@
                 <a:ea typeface="Arial"/>
                 <a:cs typeface="Arial"/>
               </a:rPr>
-              <a:t>40</a:t>
-            </a:r>
-          </a:p>
-        </p:txBody>
-      </p:sp>
-      <p:graphicFrame>
-        <p:nvGraphicFramePr>
-          <p:cNvPr id="16" name=""/>
-          <p:cNvGraphicFramePr/>
-          <p:nvPr/>
-        </p:nvGraphicFramePr>
-        <p:xfrm>
-          <a:off xmlns:a="http://schemas.openxmlformats.org/drawingml/2006/main" x="822960" y="1645920"/>
-          <a:ext xmlns:a="http://schemas.openxmlformats.org/drawingml/2006/main" cx="10149840" cy="3154680"/>
-        </p:xfrm>
-        <a:graphic xmlns:a="http://schemas.openxmlformats.org/drawingml/2006/main">
-          <a:graphicData uri="http://schemas.openxmlformats.org/drawingml/2006/table">
-            <a:tbl>
-              <a:tblPr/>
-              <a:tblGrid>
-                <a:gridCol w="4023360"/>
-                <a:gridCol w="6126480"/>
-              </a:tblGrid>
-              <a:tr h="630936">
-                <a:tc>
-                  <a:txBody>
-                    <a:bodyPr/>
-                    <a:lstStyle/>
-                    <a:p>
-                      <a:r>
-                        <a:rPr sz="1728" b="1">
-                          <a:solidFill>
-                            <a:srgbClr val="FFFFFF"/>
-                          </a:solidFill>
-                          <a:latin typeface="Arial"/>
-                          <a:ea typeface="Arial"/>
-                          <a:cs typeface="Arial"/>
-                        </a:rPr>
-                        <a:t>Idea</a:t>
-                      </a:r>
-                    </a:p>
-                  </a:txBody>
-                  <a:tcPr marL="91440" marR="91440" marT="45720" marB="45720">
-                    <a:solidFill>
-                      <a:srgbClr val="70436F"/>
-                    </a:solidFill>
-                  </a:tcPr>
-                </a:tc>
-                <a:tc>
-                  <a:txBody>
-                    <a:bodyPr/>
-                    <a:lstStyle/>
-                    <a:p>
-                      <a:r>
-                        <a:rPr sz="1728" b="1">
-                          <a:solidFill>
-                            <a:srgbClr val="FFFFFF"/>
-                          </a:solidFill>
-                          <a:latin typeface="Arial"/>
-                          <a:ea typeface="Arial"/>
-                          <a:cs typeface="Arial"/>
-                        </a:rPr>
-                        <a:t>Qué revisar</a:t>
-                      </a:r>
-                    </a:p>
-                  </a:txBody>
-                  <a:tcPr marL="91440" marR="91440" marT="45720" marB="45720">
-                    <a:solidFill>
-                      <a:srgbClr val="70436F"/>
-                    </a:solidFill>
-                  </a:tcPr>
-                </a:tc>
-              </a:tr>
-              <a:tr h="630936">
-                <a:tc>
-                  <a:txBody>
-                    <a:bodyPr/>
-                    <a:lstStyle/>
-                    <a:p>
-                      <a:r>
-                        <a:rPr sz="1728" b="0">
-                          <a:solidFill>
-                            <a:srgbClr val="263442"/>
-                          </a:solidFill>
-                          <a:latin typeface="Arial"/>
-                          <a:ea typeface="Arial"/>
-                          <a:cs typeface="Arial"/>
-                        </a:rPr>
-                        <a:t>Definimos relaciones</a:t>
-                      </a:r>
-                    </a:p>
-                  </a:txBody>
-                  <a:tcPr marL="91440" marR="91440" marT="45720" marB="45720">
-                    <a:solidFill>
-                      <a:srgbClr val="F5EFF5"/>
-                    </a:solidFill>
-                  </a:tcPr>
-                </a:tc>
-                <a:tc>
-                  <a:txBody>
-                    <a:bodyPr/>
-                    <a:lstStyle/>
-                    <a:p>
-                      <a:r>
-                        <a:rPr sz="1728" b="0">
-                          <a:solidFill>
-                            <a:srgbClr val="263442"/>
-                          </a:solidFill>
-                          <a:latin typeface="Arial"/>
-                          <a:ea typeface="Arial"/>
-                          <a:cs typeface="Arial"/>
-                        </a:rPr>
-                        <a:t>Escribir primero sintaxis, semántica y firma.</a:t>
-                      </a:r>
-                    </a:p>
-                  </a:txBody>
-                  <a:tcPr marL="91440" marR="91440" marT="45720" marB="45720">
-                    <a:solidFill>
-                      <a:srgbClr val="F5EFF5"/>
-                    </a:solidFill>
-                  </a:tcPr>
-                </a:tc>
-              </a:tr>
-              <a:tr h="630936">
-                <a:tc>
-                  <a:txBody>
-                    <a:bodyPr/>
-                    <a:lstStyle/>
-                    <a:p>
-                      <a:r>
-                        <a:rPr sz="1728" b="0">
-                          <a:solidFill>
-                            <a:srgbClr val="263442"/>
-                          </a:solidFill>
-                          <a:latin typeface="Arial"/>
-                          <a:ea typeface="Arial"/>
-                          <a:cs typeface="Arial"/>
-                        </a:rPr>
-                        <a:t>El intérprete busca pruebas</a:t>
-                      </a:r>
-                    </a:p>
-                  </a:txBody>
-                  <a:tcPr marL="91440" marR="91440" marT="45720" marB="45720">
-                    <a:solidFill>
-                      <a:srgbClr val="FFFFFF"/>
-                    </a:solidFill>
-                  </a:tcPr>
-                </a:tc>
-                <a:tc>
-                  <a:txBody>
-                    <a:bodyPr/>
-                    <a:lstStyle/>
-                    <a:p>
-                      <a:r>
-                        <a:rPr sz="1728" b="0">
-                          <a:solidFill>
-                            <a:srgbClr val="263442"/>
-                          </a:solidFill>
-                          <a:latin typeface="Arial"/>
-                          <a:ea typeface="Arial"/>
-                          <a:cs typeface="Arial"/>
-                        </a:rPr>
-                        <a:t>Leer los objetivos y las sustituciones del árbol.</a:t>
-                      </a:r>
-                    </a:p>
-                  </a:txBody>
-                  <a:tcPr marL="91440" marR="91440" marT="45720" marB="45720">
-                    <a:solidFill>
-                      <a:srgbClr val="FFFFFF"/>
-                    </a:solidFill>
-                  </a:tcPr>
-                </a:tc>
-              </a:tr>
-              <a:tr h="630936">
-                <a:tc>
-                  <a:txBody>
-                    <a:bodyPr/>
-                    <a:lstStyle/>
-                    <a:p>
-                      <a:r>
-                        <a:rPr sz="1728" b="0">
-                          <a:solidFill>
-                            <a:srgbClr val="263442"/>
-                          </a:solidFill>
-                          <a:latin typeface="Arial"/>
-                          <a:ea typeface="Arial"/>
-                          <a:cs typeface="Arial"/>
-                        </a:rPr>
-                        <a:t>La sintaxis distingue nombres</a:t>
-                      </a:r>
-                    </a:p>
-                  </a:txBody>
-                  <a:tcPr marL="91440" marR="91440" marT="45720" marB="45720">
-                    <a:solidFill>
-                      <a:srgbClr val="F5EFF5"/>
-                    </a:solidFill>
-                  </a:tcPr>
-                </a:tc>
-                <a:tc>
-                  <a:txBody>
-                    <a:bodyPr/>
-                    <a:lstStyle/>
-                    <a:p>
-                      <a:r>
-                        <a:rPr sz="1728" b="0">
-                          <a:solidFill>
-                            <a:srgbClr val="263442"/>
-                          </a:solidFill>
-                          <a:latin typeface="Arial"/>
-                          <a:ea typeface="Arial"/>
-                          <a:cs typeface="Arial"/>
-                        </a:rPr>
-                        <a:t>Natural es variable. S(0) no es un término válido.</a:t>
-                      </a:r>
-                    </a:p>
-                  </a:txBody>
-                  <a:tcPr marL="91440" marR="91440" marT="45720" marB="45720">
-                    <a:solidFill>
-                      <a:srgbClr val="F5EFF5"/>
-                    </a:solidFill>
-                  </a:tcPr>
-                </a:tc>
-              </a:tr>
-              <a:tr h="630936">
-                <a:tc>
-                  <a:txBody>
-                    <a:bodyPr/>
-                    <a:lstStyle/>
-                    <a:p>
-                      <a:r>
-                        <a:rPr sz="1728" b="0">
-                          <a:solidFill>
-                            <a:srgbClr val="263442"/>
-                          </a:solidFill>
-                          <a:latin typeface="Arial"/>
-                          <a:ea typeface="Arial"/>
-                          <a:cs typeface="Arial"/>
-                        </a:rPr>
-                        <a:t>Cargamos y preguntamos</a:t>
-                      </a:r>
-                    </a:p>
-                  </a:txBody>
-                  <a:tcPr marL="91440" marR="91440" marT="45720" marB="45720">
-                    <a:solidFill>
-                      <a:srgbClr val="FFFFFF"/>
-                    </a:solidFill>
-                  </a:tcPr>
-                </a:tc>
-                <a:tc>
-                  <a:txBody>
-                    <a:bodyPr/>
-                    <a:lstStyle/>
-                    <a:p>
-                      <a:r>
-                        <a:rPr sz="1728" b="0">
-                          <a:solidFill>
-                            <a:srgbClr val="263442"/>
-                          </a:solidFill>
-                          <a:latin typeface="Arial"/>
-                          <a:ea typeface="Arial"/>
-                          <a:cs typeface="Arial"/>
-                        </a:rPr>
-                        <a:t>Guardar, consult(natural). y terminar la consulta con .</a:t>
-                      </a:r>
-                    </a:p>
-                  </a:txBody>
-                  <a:tcPr marL="91440" marR="91440" marT="45720" marB="45720">
-                    <a:solidFill>
-                      <a:srgbClr val="FFFFFF"/>
-                    </a:solidFill>
-                  </a:tcPr>
-                </a:tc>
-              </a:tr>
-            </a:tbl>
-          </a:graphicData>
-        </a:graphic>
-      </p:graphicFrame>
+              <a:t>2</a:t>
+            </a:r>
+          </a:p>
+        </p:txBody>
+      </p:sp>
+      <p:sp>
+        <p:nvSpPr>
+          <p:cNvPr id="7" name="">
+            <a:extLst xmlns:a="http://schemas.openxmlformats.org/drawingml/2006/main">
+              <a:ext uri="{FF2B5EF4-FFF2-40B4-BE49-F238E27FC236}">
+                <a16:creationId xmlns:a16="http://schemas.microsoft.com/office/drawing/2014/main" id="{F111D848-80DB-4ECF-A0C5-5B47986CA2CA}"/>
+              </a:ext>
+            </a:extLst>
+          </p:cNvPr>
+          <p:cNvSpPr>
+            <a:spLocks xmlns:a="http://schemas.openxmlformats.org/drawingml/2006/main" noGrp="1"/>
+          </p:cNvSpPr>
+          <p:nvPr/>
+        </p:nvSpPr>
+        <p:spPr>
+          <a:xfrm xmlns:a="http://schemas.openxmlformats.org/drawingml/2006/main">
+            <a:off x="804672" y="1938528"/>
+            <a:ext cx="2743200" cy="457200"/>
+          </a:xfrm>
+          <a:prstGeom xmlns:a="http://schemas.openxmlformats.org/drawingml/2006/main" prst="rect">
+            <a:avLst/>
+          </a:prstGeom>
+          <a:noFill xmlns:a="http://schemas.openxmlformats.org/drawingml/2006/main"/>
+          <a:ln xmlns:a="http://schemas.openxmlformats.org/drawingml/2006/main" w="0">
+            <a:noFill/>
+          </a:ln>
+        </p:spPr>
+        <p:txBody>
+          <a:bodyPr xmlns:a="http://schemas.openxmlformats.org/drawingml/2006/main">
+            <a:noAutofit/>
+          </a:bodyPr>
+          <a:lstStyle xmlns:a="http://schemas.openxmlformats.org/drawingml/2006/main"/>
+          <a:p xmlns:a="http://schemas.openxmlformats.org/drawingml/2006/main">
+            <a:pPr algn="l">
+              <a:defRPr sz="2016" b="1">
+                <a:solidFill>
+                  <a:srgbClr val="70436F"/>
+                </a:solidFill>
+                <a:latin typeface="Arial"/>
+                <a:ea typeface="Arial"/>
+                <a:cs typeface="Arial"/>
+              </a:defRPr>
+            </a:pPr>
+            <a:r>
+              <a:rPr sz="2016" b="1">
+                <a:solidFill>
+                  <a:srgbClr val="70436F"/>
+                </a:solidFill>
+                <a:latin typeface="Arial"/>
+                <a:ea typeface="Arial"/>
+                <a:cs typeface="Arial"/>
+              </a:rPr>
+              <a:t>Lunes</a:t>
+            </a:r>
+          </a:p>
+        </p:txBody>
+      </p:sp>
       <p:sp>
         <p:nvSpPr>
           <p:cNvPr id="8" name="">
             <a:extLst xmlns:a="http://schemas.openxmlformats.org/drawingml/2006/main">
               <a:ext uri="{FF2B5EF4-FFF2-40B4-BE49-F238E27FC236}">
-                <a16:creationId xmlns:a16="http://schemas.microsoft.com/office/drawing/2014/main" id="{FC7800CC-4D8C-451B-9CFF-6EFCD2E0D9C1}"/>
-              </a:ext>
-            </a:extLst>
-          </p:cNvPr>
-          <p:cNvSpPr>
-            <a:spLocks xmlns:a="http://schemas.openxmlformats.org/drawingml/2006/main" noGrp="1"/>
-          </p:cNvSpPr>
-          <p:nvPr/>
-        </p:nvSpPr>
-        <p:spPr>
-          <a:xfrm xmlns:a="http://schemas.openxmlformats.org/drawingml/2006/main">
-            <a:off x="822960" y="5303520"/>
-            <a:ext cx="10149840" cy="594360"/>
-          </a:xfrm>
-          <a:prstGeom xmlns:a="http://schemas.openxmlformats.org/drawingml/2006/main" prst="rect">
-            <a:avLst/>
-          </a:prstGeom>
-          <a:noFill xmlns:a="http://schemas.openxmlformats.org/drawingml/2006/main"/>
-          <a:ln xmlns:a="http://schemas.openxmlformats.org/drawingml/2006/main" w="0">
-            <a:noFill/>
-          </a:ln>
-        </p:spPr>
-        <p:txBody>
-          <a:bodyPr xmlns:a="http://schemas.openxmlformats.org/drawingml/2006/main">
-            <a:noAutofit/>
-          </a:bodyPr>
-          <a:lstStyle xmlns:a="http://schemas.openxmlformats.org/drawingml/2006/main"/>
-          <a:p xmlns:a="http://schemas.openxmlformats.org/drawingml/2006/main">
-            <a:pPr algn="l">
-              <a:defRPr sz="2376" b="1">
+                <a16:creationId xmlns:a16="http://schemas.microsoft.com/office/drawing/2014/main" id="{D4FE7C82-36DD-4CF3-ACDD-3D0DCA4FCC0F}"/>
+              </a:ext>
+            </a:extLst>
+          </p:cNvPr>
+          <p:cNvSpPr>
+            <a:spLocks xmlns:a="http://schemas.openxmlformats.org/drawingml/2006/main" noGrp="1"/>
+          </p:cNvSpPr>
+          <p:nvPr/>
+        </p:nvSpPr>
+        <p:spPr>
+          <a:xfrm xmlns:a="http://schemas.openxmlformats.org/drawingml/2006/main">
+            <a:off x="4297680" y="1938528"/>
+            <a:ext cx="5029200" cy="457200"/>
+          </a:xfrm>
+          <a:prstGeom xmlns:a="http://schemas.openxmlformats.org/drawingml/2006/main" prst="rect">
+            <a:avLst/>
+          </a:prstGeom>
+          <a:noFill xmlns:a="http://schemas.openxmlformats.org/drawingml/2006/main"/>
+          <a:ln xmlns:a="http://schemas.openxmlformats.org/drawingml/2006/main" w="0">
+            <a:noFill/>
+          </a:ln>
+        </p:spPr>
+        <p:txBody>
+          <a:bodyPr xmlns:a="http://schemas.openxmlformats.org/drawingml/2006/main">
+            <a:noAutofit/>
+          </a:bodyPr>
+          <a:lstStyle xmlns:a="http://schemas.openxmlformats.org/drawingml/2006/main"/>
+          <a:p xmlns:a="http://schemas.openxmlformats.org/drawingml/2006/main">
+            <a:pPr algn="l">
+              <a:defRPr sz="2160" b="1">
+                <a:solidFill>
+                  <a:srgbClr val="263442"/>
+                </a:solidFill>
+                <a:latin typeface="Arial"/>
+                <a:ea typeface="Arial"/>
+                <a:cs typeface="Arial"/>
+              </a:defRPr>
+            </a:pPr>
+            <a:r>
+              <a:rPr sz="2160" b="1">
+                <a:solidFill>
+                  <a:srgbClr val="263442"/>
+                </a:solidFill>
+                <a:latin typeface="Arial"/>
+                <a:ea typeface="Arial"/>
+                <a:cs typeface="Arial"/>
+              </a:rPr>
+              <a:t>09:00–10:30</a:t>
+            </a:r>
+          </a:p>
+        </p:txBody>
+      </p:sp>
+      <p:sp>
+        <p:nvSpPr>
+          <p:cNvPr id="9" name="">
+            <a:extLst xmlns:a="http://schemas.openxmlformats.org/drawingml/2006/main">
+              <a:ext uri="{FF2B5EF4-FFF2-40B4-BE49-F238E27FC236}">
+                <a16:creationId xmlns:a16="http://schemas.microsoft.com/office/drawing/2014/main" id="{D1271E40-94A0-44F9-94DA-E1CAD5B34850}"/>
+              </a:ext>
+            </a:extLst>
+          </p:cNvPr>
+          <p:cNvSpPr>
+            <a:spLocks xmlns:a="http://schemas.openxmlformats.org/drawingml/2006/main" noGrp="1"/>
+          </p:cNvSpPr>
+          <p:nvPr/>
+        </p:nvSpPr>
+        <p:spPr>
+          <a:xfrm xmlns:a="http://schemas.openxmlformats.org/drawingml/2006/main">
+            <a:off x="804672" y="2944368"/>
+            <a:ext cx="2743200" cy="457200"/>
+          </a:xfrm>
+          <a:prstGeom xmlns:a="http://schemas.openxmlformats.org/drawingml/2006/main" prst="rect">
+            <a:avLst/>
+          </a:prstGeom>
+          <a:noFill xmlns:a="http://schemas.openxmlformats.org/drawingml/2006/main"/>
+          <a:ln xmlns:a="http://schemas.openxmlformats.org/drawingml/2006/main" w="0">
+            <a:noFill/>
+          </a:ln>
+        </p:spPr>
+        <p:txBody>
+          <a:bodyPr xmlns:a="http://schemas.openxmlformats.org/drawingml/2006/main">
+            <a:noAutofit/>
+          </a:bodyPr>
+          <a:lstStyle xmlns:a="http://schemas.openxmlformats.org/drawingml/2006/main"/>
+          <a:p xmlns:a="http://schemas.openxmlformats.org/drawingml/2006/main">
+            <a:pPr algn="l">
+              <a:defRPr sz="2016" b="1">
                 <a:solidFill>
                   <a:srgbClr val="70436F"/>
                 </a:solidFill>
-                <a:latin typeface="Consolas"/>
-                <a:ea typeface="Consolas"/>
-                <a:cs typeface="Consolas"/>
-              </a:defRPr>
-            </a:pPr>
-            <a:r>
-              <a:rPr sz="2376" b="1">
+                <a:latin typeface="Arial"/>
+                <a:ea typeface="Arial"/>
+                <a:cs typeface="Arial"/>
+              </a:defRPr>
+            </a:pPr>
+            <a:r>
+              <a:rPr sz="2016" b="1">
                 <a:solidFill>
                   <a:srgbClr val="70436F"/>
                 </a:solidFill>
-                <a:latin typeface="Consolas"/>
-                <a:ea typeface="Consolas"/>
-                <a:cs typeface="Consolas"/>
-              </a:rPr>
-              <a:t>Una respuesta: .      Otra respuesta: ;</a:t>
-            </a:r>
-          </a:p>
-        </p:txBody>
-      </p:sp>
-      <p:sp>
-        <p:nvSpPr>
-          <p:cNvPr id="9" name="">
-            <a:extLst xmlns:a="http://schemas.openxmlformats.org/drawingml/2006/main">
-              <a:ext uri="{FF2B5EF4-FFF2-40B4-BE49-F238E27FC236}">
-                <a16:creationId xmlns:a16="http://schemas.microsoft.com/office/drawing/2014/main" id="{49F73912-5525-4536-8889-AD6BA44C8393}"/>
-              </a:ext>
-            </a:extLst>
-          </p:cNvPr>
-          <p:cNvSpPr>
-            <a:spLocks xmlns:a="http://schemas.openxmlformats.org/drawingml/2006/main" noGrp="1"/>
-          </p:cNvSpPr>
-          <p:nvPr/>
-        </p:nvSpPr>
-        <p:spPr>
-          <a:xfrm xmlns:a="http://schemas.openxmlformats.org/drawingml/2006/main">
-            <a:off x="822960" y="6089904"/>
-            <a:ext cx="10149840" cy="173736"/>
-          </a:xfrm>
-          <a:prstGeom xmlns:a="http://schemas.openxmlformats.org/drawingml/2006/main" prst="rect">
-            <a:avLst/>
-          </a:prstGeom>
-          <a:noFill xmlns:a="http://schemas.openxmlformats.org/drawingml/2006/main"/>
-          <a:ln xmlns:a="http://schemas.openxmlformats.org/drawingml/2006/main" w="0">
-            <a:noFill/>
-          </a:ln>
-        </p:spPr>
-        <p:txBody>
-          <a:bodyPr xmlns:a="http://schemas.openxmlformats.org/drawingml/2006/main">
-            <a:noAutofit/>
-          </a:bodyPr>
-          <a:lstStyle xmlns:a="http://schemas.openxmlformats.org/drawingml/2006/main"/>
-          <a:p xmlns:a="http://schemas.openxmlformats.org/drawingml/2006/main">
-            <a:pPr algn="l">
-              <a:defRPr sz="864" b="0">
-                <a:solidFill>
-                  <a:srgbClr val="60707B"/>
-                </a:solidFill>
-                <a:latin typeface="Arial"/>
-                <a:ea typeface="Arial"/>
-                <a:cs typeface="Arial"/>
-              </a:defRPr>
-            </a:pPr>
-            <a:r>
-              <a:rPr sz="864" b="0">
-                <a:solidFill>
-                  <a:srgbClr val="60707B"/>
-                </a:solidFill>
-                <a:latin typeface="Arial"/>
-                <a:ea typeface="Arial"/>
-                <a:cs typeface="Arial"/>
-              </a:rPr>
-              <a:t>Material de clase: natural · Programación lógica e inteligencia artificial · Primeros pasos II · Manual de SWI-Prolog.</a:t>
+                <a:latin typeface="Arial"/>
+                <a:ea typeface="Arial"/>
+                <a:cs typeface="Arial"/>
+              </a:rPr>
+              <a:t>Jueves</a:t>
+            </a:r>
+          </a:p>
+        </p:txBody>
+      </p:sp>
+      <p:sp>
+        <p:nvSpPr>
+          <p:cNvPr id="10" name="">
+            <a:extLst xmlns:a="http://schemas.openxmlformats.org/drawingml/2006/main">
+              <a:ext uri="{FF2B5EF4-FFF2-40B4-BE49-F238E27FC236}">
+                <a16:creationId xmlns:a16="http://schemas.microsoft.com/office/drawing/2014/main" id="{76B2AFD7-D6E6-4024-A475-CF8CBC8EA5F6}"/>
+              </a:ext>
+            </a:extLst>
+          </p:cNvPr>
+          <p:cNvSpPr>
+            <a:spLocks xmlns:a="http://schemas.openxmlformats.org/drawingml/2006/main" noGrp="1"/>
+          </p:cNvSpPr>
+          <p:nvPr/>
+        </p:nvSpPr>
+        <p:spPr>
+          <a:xfrm xmlns:a="http://schemas.openxmlformats.org/drawingml/2006/main">
+            <a:off x="4297680" y="2944368"/>
+            <a:ext cx="5029200" cy="457200"/>
+          </a:xfrm>
+          <a:prstGeom xmlns:a="http://schemas.openxmlformats.org/drawingml/2006/main" prst="rect">
+            <a:avLst/>
+          </a:prstGeom>
+          <a:noFill xmlns:a="http://schemas.openxmlformats.org/drawingml/2006/main"/>
+          <a:ln xmlns:a="http://schemas.openxmlformats.org/drawingml/2006/main" w="0">
+            <a:noFill/>
+          </a:ln>
+        </p:spPr>
+        <p:txBody>
+          <a:bodyPr xmlns:a="http://schemas.openxmlformats.org/drawingml/2006/main">
+            <a:noAutofit/>
+          </a:bodyPr>
+          <a:lstStyle xmlns:a="http://schemas.openxmlformats.org/drawingml/2006/main"/>
+          <a:p xmlns:a="http://schemas.openxmlformats.org/drawingml/2006/main">
+            <a:pPr algn="l">
+              <a:defRPr sz="2160" b="1">
+                <a:solidFill>
+                  <a:srgbClr val="263442"/>
+                </a:solidFill>
+                <a:latin typeface="Arial"/>
+                <a:ea typeface="Arial"/>
+                <a:cs typeface="Arial"/>
+              </a:defRPr>
+            </a:pPr>
+            <a:r>
+              <a:rPr sz="2160" b="1">
+                <a:solidFill>
+                  <a:srgbClr val="263442"/>
+                </a:solidFill>
+                <a:latin typeface="Arial"/>
+                <a:ea typeface="Arial"/>
+                <a:cs typeface="Arial"/>
+              </a:rPr>
+              <a:t>15:00–16:30</a:t>
+            </a:r>
+          </a:p>
+        </p:txBody>
+      </p:sp>
+      <p:sp>
+        <p:nvSpPr>
+          <p:cNvPr id="11" name="">
+            <a:extLst xmlns:a="http://schemas.openxmlformats.org/drawingml/2006/main">
+              <a:ext uri="{FF2B5EF4-FFF2-40B4-BE49-F238E27FC236}">
+                <a16:creationId xmlns:a16="http://schemas.microsoft.com/office/drawing/2014/main" id="{FDE15732-0CEC-4149-ADFE-C66B21EB90C4}"/>
+              </a:ext>
+            </a:extLst>
+          </p:cNvPr>
+          <p:cNvSpPr>
+            <a:spLocks xmlns:a="http://schemas.openxmlformats.org/drawingml/2006/main" noGrp="1"/>
+          </p:cNvSpPr>
+          <p:nvPr/>
+        </p:nvSpPr>
+        <p:spPr>
+          <a:xfrm xmlns:a="http://schemas.openxmlformats.org/drawingml/2006/main">
+            <a:off x="804672" y="4297680"/>
+            <a:ext cx="9966960" cy="493776"/>
+          </a:xfrm>
+          <a:prstGeom xmlns:a="http://schemas.openxmlformats.org/drawingml/2006/main" prst="rect">
+            <a:avLst/>
+          </a:prstGeom>
+          <a:noFill xmlns:a="http://schemas.openxmlformats.org/drawingml/2006/main"/>
+          <a:ln xmlns:a="http://schemas.openxmlformats.org/drawingml/2006/main" w="0">
+            <a:noFill/>
+          </a:ln>
+        </p:spPr>
+        <p:txBody>
+          <a:bodyPr xmlns:a="http://schemas.openxmlformats.org/drawingml/2006/main">
+            <a:noAutofit/>
+          </a:bodyPr>
+          <a:lstStyle xmlns:a="http://schemas.openxmlformats.org/drawingml/2006/main"/>
+          <a:p xmlns:a="http://schemas.openxmlformats.org/drawingml/2006/main">
+            <a:pPr algn="l">
+              <a:defRPr sz="1944" b="0">
+                <a:solidFill>
+                  <a:srgbClr val="263442"/>
+                </a:solidFill>
+                <a:latin typeface="Arial"/>
+                <a:ea typeface="Arial"/>
+                <a:cs typeface="Arial"/>
+              </a:defRPr>
+            </a:pPr>
+            <a:r>
+              <a:rPr sz="1944" b="0">
+                <a:solidFill>
+                  <a:srgbClr val="263442"/>
+                </a:solidFill>
+                <a:latin typeface="Arial"/>
+                <a:ea typeface="Arial"/>
+                <a:cs typeface="Arial"/>
+              </a:rPr>
+              <a:t>Laboratorio de Ciencia Computacional</a:t>
+            </a:r>
+          </a:p>
+        </p:txBody>
+      </p:sp>
+      <p:sp>
+        <p:nvSpPr>
+          <p:cNvPr id="12" name="">
+            <a:extLst xmlns:a="http://schemas.openxmlformats.org/drawingml/2006/main">
+              <a:ext uri="{FF2B5EF4-FFF2-40B4-BE49-F238E27FC236}">
+                <a16:creationId xmlns:a16="http://schemas.microsoft.com/office/drawing/2014/main" id="{6B2C3566-A45B-4621-8672-041B3D85548E}"/>
+              </a:ext>
+            </a:extLst>
+          </p:cNvPr>
+          <p:cNvSpPr>
+            <a:spLocks xmlns:a="http://schemas.openxmlformats.org/drawingml/2006/main" noGrp="1"/>
+          </p:cNvSpPr>
+          <p:nvPr/>
+        </p:nvSpPr>
+        <p:spPr>
+          <a:xfrm xmlns:a="http://schemas.openxmlformats.org/drawingml/2006/main">
+            <a:off x="804672" y="5138928"/>
+            <a:ext cx="9966960" cy="493776"/>
+          </a:xfrm>
+          <a:prstGeom xmlns:a="http://schemas.openxmlformats.org/drawingml/2006/main" prst="rect">
+            <a:avLst/>
+          </a:prstGeom>
+          <a:noFill xmlns:a="http://schemas.openxmlformats.org/drawingml/2006/main"/>
+          <a:ln xmlns:a="http://schemas.openxmlformats.org/drawingml/2006/main" w="0">
+            <a:noFill/>
+          </a:ln>
+        </p:spPr>
+        <p:txBody>
+          <a:bodyPr xmlns:a="http://schemas.openxmlformats.org/drawingml/2006/main">
+            <a:noAutofit/>
+          </a:bodyPr>
+          <a:lstStyle xmlns:a="http://schemas.openxmlformats.org/drawingml/2006/main"/>
+          <a:p xmlns:a="http://schemas.openxmlformats.org/drawingml/2006/main">
+            <a:pPr algn="l">
+              <a:defRPr sz="1872" b="1">
+                <a:solidFill>
+                  <a:srgbClr val="70436F"/>
+                </a:solidFill>
+                <a:latin typeface="Arial"/>
+                <a:ea typeface="Arial"/>
+                <a:cs typeface="Arial"/>
+              </a:defRPr>
+            </a:pPr>
+            <a:r>
+              <a:rPr sz="1872" b="1">
+                <a:solidFill>
+                  <a:srgbClr val="70436F"/>
+                </a:solidFill>
+                <a:latin typeface="Arial"/>
+                <a:ea typeface="Arial"/>
+                <a:cs typeface="Arial"/>
+              </a:rPr>
+              <a:t>3 horas concertadas · erik.figueiral.alonso@uvigo.gal</a:t>
             </a:r>
           </a:p>
         </p:txBody>
@@ -30726,7 +30682,7 @@
     </p:spTree>
     <p:extLst>
       <p:ext uri="{BB962C8B-B14F-4D97-AF65-F5344CB8AC3E}">
-        <p14:creationId xmlns:p14="http://schemas.microsoft.com/office/powerpoint/2010/main" val="1273247336"/>
+        <p14:creationId xmlns:p14="http://schemas.microsoft.com/office/powerpoint/2010/main" val="1636389764"/>
       </p:ext>
     </p:extLst>
   </p:cSld>
@@ -31035,7 +30991,7 @@
                 <a:ea typeface="Arial"/>
                 <a:cs typeface="Arial"/>
               </a:rPr>
-              <a:t>5</a:t>
+              <a:t>6</a:t>
             </a:r>
           </a:p>
         </p:txBody>
@@ -31891,7 +31847,7 @@
                 <a:ea typeface="Arial"/>
                 <a:cs typeface="Arial"/>
               </a:rPr>
-              <a:t>6</a:t>
+              <a:t>7</a:t>
             </a:r>
           </a:p>
         </p:txBody>
@@ -32827,7 +32783,7 @@
                 <a:ea typeface="Arial"/>
                 <a:cs typeface="Arial"/>
               </a:rPr>
-              <a:t>7</a:t>
+              <a:t>8</a:t>
             </a:r>
           </a:p>
         </p:txBody>
@@ -33649,7 +33605,7 @@
                 <a:ea typeface="Arial"/>
                 <a:cs typeface="Arial"/>
               </a:rPr>
-              <a:t>8</a:t>
+              <a:t>9</a:t>
             </a:r>
           </a:p>
         </p:txBody>
@@ -34439,7 +34395,7 @@
                 <a:ea typeface="Arial"/>
                 <a:cs typeface="Arial"/>
               </a:rPr>
-              <a:t>9</a:t>
+              <a:t>10</a:t>
             </a:r>
           </a:p>
         </p:txBody>

</xml_diff>